<commit_message>
Emulazione web app e patch xss
</commit_message>
<xml_diff>
--- a/file/documents/CurcioRabbiaVociPresentation.pptx
+++ b/file/documents/CurcioRabbiaVociPresentation.pptx
@@ -5,13 +5,16 @@
     <p:sldMasterId id="2147483738" r:id="rId1"/>
   </p:sldMasterIdLst>
   <p:notesMasterIdLst>
-    <p:notesMasterId r:id="rId6"/>
+    <p:notesMasterId r:id="rId9"/>
   </p:notesMasterIdLst>
   <p:sldIdLst>
     <p:sldId id="256" r:id="rId2"/>
     <p:sldId id="257" r:id="rId3"/>
-    <p:sldId id="267" r:id="rId4"/>
-    <p:sldId id="266" r:id="rId5"/>
+    <p:sldId id="272" r:id="rId4"/>
+    <p:sldId id="271" r:id="rId5"/>
+    <p:sldId id="269" r:id="rId6"/>
+    <p:sldId id="270" r:id="rId7"/>
+    <p:sldId id="266" r:id="rId8"/>
   </p:sldIdLst>
   <p:sldSz cx="12192000" cy="6858000"/>
   <p:notesSz cx="6858000" cy="9144000"/>
@@ -118,96 +121,6 @@
 </p:presentation>
 </file>
 
-<file path=ppt/revisionInfo.xml><?xml version="1.0" encoding="utf-8"?>
-<p1510:revInfo xmlns:a="http://schemas.openxmlformats.org/drawingml/2006/main" xmlns:r="http://schemas.openxmlformats.org/officeDocument/2006/relationships" xmlns:p1510="http://schemas.microsoft.com/office/powerpoint/2015/10/main">
-  <p1510:revLst>
-    <p1510:client id="{AA6D4A1A-6692-4EC0-B24A-95CE0C4959E7}" v="1" dt="2026-03-11T10:13:27.477"/>
-  </p1510:revLst>
-</p1510:revInfo>
-</file>
-
-<file path=ppt/changesInfos/changesInfo1.xml><?xml version="1.0" encoding="utf-8"?>
-<pc:chgInfo xmlns:a="http://schemas.openxmlformats.org/drawingml/2006/main" xmlns:r="http://schemas.openxmlformats.org/officeDocument/2006/relationships" xmlns:ac="http://schemas.microsoft.com/office/drawing/2013/main/command" xmlns:pc="http://schemas.microsoft.com/office/powerpoint/2013/main/command">
-  <pc:docChgLst>
-    <pc:chgData name="GREGORIO VOCI" userId="45b1c0f7-4f51-4b28-bcf9-00831182d00a" providerId="ADAL" clId="{6AEC2FAA-4A34-4FA4-9916-D0032CAD2615}"/>
-    <pc:docChg chg="custSel addSld delSld modSld sldOrd">
-      <pc:chgData name="GREGORIO VOCI" userId="45b1c0f7-4f51-4b28-bcf9-00831182d00a" providerId="ADAL" clId="{6AEC2FAA-4A34-4FA4-9916-D0032CAD2615}" dt="2026-03-11T10:19:03.139" v="805" actId="20577"/>
-      <pc:docMkLst>
-        <pc:docMk/>
-      </pc:docMkLst>
-      <pc:sldChg chg="modSp mod">
-        <pc:chgData name="GREGORIO VOCI" userId="45b1c0f7-4f51-4b28-bcf9-00831182d00a" providerId="ADAL" clId="{6AEC2FAA-4A34-4FA4-9916-D0032CAD2615}" dt="2026-03-11T10:19:03.139" v="805" actId="20577"/>
-        <pc:sldMkLst>
-          <pc:docMk/>
-          <pc:sldMk cId="4267515398" sldId="257"/>
-        </pc:sldMkLst>
-        <pc:spChg chg="mod">
-          <ac:chgData name="GREGORIO VOCI" userId="45b1c0f7-4f51-4b28-bcf9-00831182d00a" providerId="ADAL" clId="{6AEC2FAA-4A34-4FA4-9916-D0032CAD2615}" dt="2026-03-11T10:01:31.309" v="21" actId="20577"/>
-          <ac:spMkLst>
-            <pc:docMk/>
-            <pc:sldMk cId="4267515398" sldId="257"/>
-            <ac:spMk id="2" creationId="{080F90A3-8003-4C2F-5665-A58573D12E0B}"/>
-          </ac:spMkLst>
-        </pc:spChg>
-        <pc:spChg chg="mod">
-          <ac:chgData name="GREGORIO VOCI" userId="45b1c0f7-4f51-4b28-bcf9-00831182d00a" providerId="ADAL" clId="{6AEC2FAA-4A34-4FA4-9916-D0032CAD2615}" dt="2026-03-11T10:19:03.139" v="805" actId="20577"/>
-          <ac:spMkLst>
-            <pc:docMk/>
-            <pc:sldMk cId="4267515398" sldId="257"/>
-            <ac:spMk id="6" creationId="{6B50B163-6879-A9BC-86B5-69FA3500B115}"/>
-          </ac:spMkLst>
-        </pc:spChg>
-      </pc:sldChg>
-      <pc:sldChg chg="modSp del mod ord">
-        <pc:chgData name="GREGORIO VOCI" userId="45b1c0f7-4f51-4b28-bcf9-00831182d00a" providerId="ADAL" clId="{6AEC2FAA-4A34-4FA4-9916-D0032CAD2615}" dt="2026-03-11T10:13:47.911" v="232" actId="47"/>
-        <pc:sldMkLst>
-          <pc:docMk/>
-          <pc:sldMk cId="4148344031" sldId="260"/>
-        </pc:sldMkLst>
-        <pc:spChg chg="mod">
-          <ac:chgData name="GREGORIO VOCI" userId="45b1c0f7-4f51-4b28-bcf9-00831182d00a" providerId="ADAL" clId="{6AEC2FAA-4A34-4FA4-9916-D0032CAD2615}" dt="2026-03-11T10:05:15.695" v="65" actId="27636"/>
-          <ac:spMkLst>
-            <pc:docMk/>
-            <pc:sldMk cId="4148344031" sldId="260"/>
-            <ac:spMk id="2" creationId="{A8CCFEFD-8BED-82FA-BB41-07F212EA6FA9}"/>
-          </ac:spMkLst>
-        </pc:spChg>
-      </pc:sldChg>
-      <pc:sldChg chg="modSp new mod">
-        <pc:chgData name="GREGORIO VOCI" userId="45b1c0f7-4f51-4b28-bcf9-00831182d00a" providerId="ADAL" clId="{6AEC2FAA-4A34-4FA4-9916-D0032CAD2615}" dt="2026-03-11T10:17:31.951" v="777" actId="20577"/>
-        <pc:sldMkLst>
-          <pc:docMk/>
-          <pc:sldMk cId="2068480627" sldId="267"/>
-        </pc:sldMkLst>
-        <pc:spChg chg="mod">
-          <ac:chgData name="GREGORIO VOCI" userId="45b1c0f7-4f51-4b28-bcf9-00831182d00a" providerId="ADAL" clId="{6AEC2FAA-4A34-4FA4-9916-D0032CAD2615}" dt="2026-03-11T10:13:45.742" v="231" actId="6549"/>
-          <ac:spMkLst>
-            <pc:docMk/>
-            <pc:sldMk cId="2068480627" sldId="267"/>
-            <ac:spMk id="2" creationId="{8BD87E4A-4250-94CF-E4F3-E4477476C883}"/>
-          </ac:spMkLst>
-        </pc:spChg>
-        <pc:spChg chg="mod">
-          <ac:chgData name="GREGORIO VOCI" userId="45b1c0f7-4f51-4b28-bcf9-00831182d00a" providerId="ADAL" clId="{6AEC2FAA-4A34-4FA4-9916-D0032CAD2615}" dt="2026-03-11T10:17:31.951" v="777" actId="20577"/>
-          <ac:spMkLst>
-            <pc:docMk/>
-            <pc:sldMk cId="2068480627" sldId="267"/>
-            <ac:spMk id="3" creationId="{E4F83AA7-ED29-DE5B-D7AB-60126D1F807A}"/>
-          </ac:spMkLst>
-        </pc:spChg>
-      </pc:sldChg>
-      <pc:sldChg chg="new del">
-        <pc:chgData name="GREGORIO VOCI" userId="45b1c0f7-4f51-4b28-bcf9-00831182d00a" providerId="ADAL" clId="{6AEC2FAA-4A34-4FA4-9916-D0032CAD2615}" dt="2026-03-11T10:18:51.146" v="779" actId="47"/>
-        <pc:sldMkLst>
-          <pc:docMk/>
-          <pc:sldMk cId="636430167" sldId="268"/>
-        </pc:sldMkLst>
-      </pc:sldChg>
-    </pc:docChg>
-  </pc:docChgLst>
-</pc:chgInfo>
-</file>
-
 <file path=ppt/notesMasters/notesMaster1.xml><?xml version="1.0" encoding="utf-8"?>
 <p:notesMaster xmlns:a="http://schemas.openxmlformats.org/drawingml/2006/main" xmlns:r="http://schemas.openxmlformats.org/officeDocument/2006/relationships" xmlns:p="http://schemas.openxmlformats.org/presentationml/2006/main">
   <p:cSld>
@@ -290,7 +203,7 @@
           <a:p>
             <a:fld id="{EAFA4191-E9D6-45E0-A2F6-55BB4A56F4E7}" type="datetimeFigureOut">
               <a:rPr lang="it-IT" smtClean="0"/>
-              <a:t>11/03/2026</a:t>
+              <a:t>16/03/2026</a:t>
             </a:fld>
             <a:endParaRPr lang="it-IT"/>
           </a:p>
@@ -622,7 +535,7 @@
           <a:p>
             <a:fld id="{9DBFCD41-E5DD-4EE5-BA62-64906D2B5268}" type="slidenum">
               <a:rPr lang="it-IT" smtClean="0"/>
-              <a:t>4</a:t>
+              <a:t>7</a:t>
             </a:fld>
             <a:endParaRPr lang="it-IT"/>
           </a:p>
@@ -753,7 +666,7 @@
           <a:p>
             <a:fld id="{E7736193-EDE3-4BB5-AE5F-E6E5472AB8BE}" type="datetimeFigureOut">
               <a:rPr lang="en-US" smtClean="0"/>
-              <a:t>3/11/2026</a:t>
+              <a:t>3/16/2026</a:t>
             </a:fld>
             <a:endParaRPr lang="en-US"/>
           </a:p>
@@ -1001,7 +914,7 @@
           <a:p>
             <a:fld id="{E7736193-EDE3-4BB5-AE5F-E6E5472AB8BE}" type="datetimeFigureOut">
               <a:rPr lang="en-US" smtClean="0"/>
-              <a:t>3/11/2026</a:t>
+              <a:t>3/16/2026</a:t>
             </a:fld>
             <a:endParaRPr lang="en-US"/>
           </a:p>
@@ -1209,7 +1122,7 @@
           <a:p>
             <a:fld id="{E7736193-EDE3-4BB5-AE5F-E6E5472AB8BE}" type="datetimeFigureOut">
               <a:rPr lang="en-US" smtClean="0"/>
-              <a:t>3/11/2026</a:t>
+              <a:t>3/16/2026</a:t>
             </a:fld>
             <a:endParaRPr lang="en-US"/>
           </a:p>
@@ -1407,7 +1320,7 @@
           <a:p>
             <a:fld id="{E7736193-EDE3-4BB5-AE5F-E6E5472AB8BE}" type="datetimeFigureOut">
               <a:rPr lang="en-US" smtClean="0"/>
-              <a:t>3/11/2026</a:t>
+              <a:t>3/16/2026</a:t>
             </a:fld>
             <a:endParaRPr lang="en-US"/>
           </a:p>
@@ -1684,7 +1597,7 @@
           <a:p>
             <a:fld id="{E7736193-EDE3-4BB5-AE5F-E6E5472AB8BE}" type="datetimeFigureOut">
               <a:rPr lang="en-US" smtClean="0"/>
-              <a:t>3/11/2026</a:t>
+              <a:t>3/16/2026</a:t>
             </a:fld>
             <a:endParaRPr lang="en-US"/>
           </a:p>
@@ -1954,7 +1867,7 @@
           <a:p>
             <a:fld id="{E7736193-EDE3-4BB5-AE5F-E6E5472AB8BE}" type="datetimeFigureOut">
               <a:rPr lang="en-US" smtClean="0"/>
-              <a:t>3/11/2026</a:t>
+              <a:t>3/16/2026</a:t>
             </a:fld>
             <a:endParaRPr lang="en-US"/>
           </a:p>
@@ -2370,7 +2283,7 @@
           <a:p>
             <a:fld id="{E7736193-EDE3-4BB5-AE5F-E6E5472AB8BE}" type="datetimeFigureOut">
               <a:rPr lang="en-US" smtClean="0"/>
-              <a:t>3/11/2026</a:t>
+              <a:t>3/16/2026</a:t>
             </a:fld>
             <a:endParaRPr lang="en-US"/>
           </a:p>
@@ -2603,7 +2516,7 @@
           <a:p>
             <a:fld id="{E7736193-EDE3-4BB5-AE5F-E6E5472AB8BE}" type="datetimeFigureOut">
               <a:rPr lang="en-US" smtClean="0"/>
-              <a:t>3/11/2026</a:t>
+              <a:t>3/16/2026</a:t>
             </a:fld>
             <a:endParaRPr lang="en-US"/>
           </a:p>
@@ -2716,7 +2629,7 @@
           <a:p>
             <a:fld id="{E7736193-EDE3-4BB5-AE5F-E6E5472AB8BE}" type="datetimeFigureOut">
               <a:rPr lang="en-US" smtClean="0"/>
-              <a:t>3/11/2026</a:t>
+              <a:t>3/16/2026</a:t>
             </a:fld>
             <a:endParaRPr lang="en-US"/>
           </a:p>
@@ -3033,7 +2946,7 @@
           <a:p>
             <a:fld id="{E7736193-EDE3-4BB5-AE5F-E6E5472AB8BE}" type="datetimeFigureOut">
               <a:rPr lang="en-US" smtClean="0"/>
-              <a:t>3/11/2026</a:t>
+              <a:t>3/16/2026</a:t>
             </a:fld>
             <a:endParaRPr lang="en-US"/>
           </a:p>
@@ -3386,7 +3299,7 @@
           <a:p>
             <a:fld id="{E7736193-EDE3-4BB5-AE5F-E6E5472AB8BE}" type="datetimeFigureOut">
               <a:rPr lang="en-US" smtClean="0"/>
-              <a:t>3/11/2026</a:t>
+              <a:t>3/16/2026</a:t>
             </a:fld>
             <a:endParaRPr lang="en-US"/>
           </a:p>
@@ -3684,7 +3597,7 @@
           <a:p>
             <a:fld id="{E7736193-EDE3-4BB5-AE5F-E6E5472AB8BE}" type="datetimeFigureOut">
               <a:rPr lang="en-US" smtClean="0"/>
-              <a:t>3/11/2026</a:t>
+              <a:t>3/16/2026</a:t>
             </a:fld>
             <a:endParaRPr lang="en-US"/>
           </a:p>
@@ -4735,7 +4648,7 @@
         </p:nvSpPr>
         <p:spPr>
           <a:xfrm>
-            <a:off x="4082466" y="959813"/>
+            <a:off x="955218" y="999255"/>
             <a:ext cx="3774518" cy="648764"/>
           </a:xfrm>
         </p:spPr>
@@ -4745,8 +4658,12 @@
           <a:p>
             <a:pPr algn="ctr"/>
             <a:r>
+              <a:rPr lang="it-IT" dirty="0" err="1"/>
+              <a:t>Available</a:t>
+            </a:r>
+            <a:r>
               <a:rPr lang="it-IT" dirty="0"/>
-              <a:t>Dispositivo</a:t>
+              <a:t> Device</a:t>
             </a:r>
           </a:p>
         </p:txBody>
@@ -4767,7 +4684,7 @@
         </p:nvSpPr>
         <p:spPr>
           <a:xfrm>
-            <a:off x="2312582" y="1619133"/>
+            <a:off x="1234197" y="1536837"/>
             <a:ext cx="5466312" cy="4212825"/>
           </a:xfrm>
           <a:prstGeom prst="rect">
@@ -4946,63 +4863,64 @@
             <a:pPr marL="0" indent="0">
               <a:buNone/>
             </a:pPr>
-            <a:r>
-              <a:rPr lang="it-IT" b="1" dirty="0" err="1"/>
+            <a:endParaRPr lang="it-IT" sz="2000" b="1" dirty="0"/>
+          </a:p>
+          <a:p>
+            <a:pPr marL="0" indent="0">
+              <a:buNone/>
+            </a:pPr>
+            <a:r>
+              <a:rPr lang="it-IT" sz="2000" b="1" dirty="0" err="1"/>
               <a:t>Aigital</a:t>
             </a:r>
             <a:r>
-              <a:rPr lang="it-IT" b="1" dirty="0"/>
+              <a:rPr lang="it-IT" sz="2000" b="1" dirty="0"/>
               <a:t> N300 </a:t>
             </a:r>
             <a:r>
-              <a:rPr lang="it-IT" b="1" dirty="0" err="1"/>
+              <a:rPr lang="it-IT" sz="2000" b="1" dirty="0" err="1"/>
               <a:t>Repeater</a:t>
             </a:r>
-            <a:endParaRPr lang="it-IT" b="1" dirty="0"/>
-          </a:p>
-          <a:p>
-            <a:r>
-              <a:rPr lang="it-IT" dirty="0" err="1"/>
-              <a:t>Wifi</a:t>
-            </a:r>
-            <a:r>
-              <a:rPr lang="it-IT" dirty="0"/>
-              <a:t> </a:t>
-            </a:r>
-            <a:r>
-              <a:rPr lang="it-IT" dirty="0" err="1"/>
-              <a:t>repeater</a:t>
-            </a:r>
-            <a:r>
-              <a:rPr lang="it-IT" dirty="0"/>
-              <a:t> in vendita online per poche decine di euro da ormai diversi anni.</a:t>
-            </a:r>
-          </a:p>
-          <a:p>
-            <a:r>
-              <a:rPr lang="it-IT" dirty="0"/>
-              <a:t>Possiede alcune vulnerabilità:</a:t>
+            <a:endParaRPr lang="it-IT" sz="2000" b="1" dirty="0"/>
+          </a:p>
+          <a:p>
+            <a:r>
+              <a:rPr lang="en-US" sz="2000" dirty="0" err="1"/>
+              <a:t>WiFi</a:t>
+            </a:r>
+            <a:r>
+              <a:rPr lang="en-US" sz="2000" dirty="0"/>
+              <a:t> repeater that has been available online for several years for a few tens of euros.</a:t>
+            </a:r>
+            <a:endParaRPr lang="it-IT" sz="2000" dirty="0"/>
+          </a:p>
+          <a:p>
+            <a:r>
+              <a:rPr lang="en-US" sz="2000" dirty="0"/>
+              <a:t>It has several vulnerabilities:</a:t>
             </a:r>
           </a:p>
           <a:p>
             <a:pPr lvl="1"/>
             <a:r>
-              <a:rPr lang="it-IT" dirty="0"/>
-              <a:t>CVE-2023-30404, RCE con severità critica;</a:t>
+              <a:rPr lang="en-US" sz="2000" b="1" dirty="0"/>
+              <a:t>CVE-2023-30404</a:t>
+            </a:r>
+            <a:r>
+              <a:rPr lang="en-US" sz="2000" dirty="0"/>
+              <a:t>, Remote Code Execution (RCE) with critical severity;</a:t>
             </a:r>
           </a:p>
           <a:p>
             <a:pPr lvl="1"/>
             <a:r>
-              <a:rPr lang="it-IT" dirty="0"/>
-              <a:t>CVE-2023-30405, XSS con severità media.</a:t>
-            </a:r>
-          </a:p>
-          <a:p>
-            <a:pPr marL="457200" lvl="1" indent="0">
-              <a:buNone/>
-            </a:pPr>
-            <a:endParaRPr lang="it-IT" dirty="0"/>
+              <a:rPr lang="en-US" sz="2000" b="1" dirty="0"/>
+              <a:t>CVE-2023-30405</a:t>
+            </a:r>
+            <a:r>
+              <a:rPr lang="en-US" sz="2000" dirty="0"/>
+              <a:t>, Cross-Site Scripting (XSS) with medium severity.</a:t>
+            </a:r>
           </a:p>
         </p:txBody>
       </p:sp>
@@ -5034,7 +4952,7 @@
         </p:blipFill>
         <p:spPr>
           <a:xfrm>
-            <a:off x="8224648" y="1205588"/>
+            <a:off x="7785736" y="1205588"/>
             <a:ext cx="2668094" cy="4446824"/>
           </a:xfrm>
           <a:prstGeom prst="rect">
@@ -5060,6 +4978,349 @@
   <p:cSld>
     <p:spTree>
       <p:nvGrpSpPr>
+        <p:cNvPr id="1" name="">
+          <a:extLst>
+            <a:ext uri="{FF2B5EF4-FFF2-40B4-BE49-F238E27FC236}">
+              <a16:creationId xmlns:a16="http://schemas.microsoft.com/office/drawing/2014/main" id="{F681FED8-AED3-1CCB-3A62-07151F02D29B}"/>
+            </a:ext>
+          </a:extLst>
+        </p:cNvPr>
+        <p:cNvGrpSpPr/>
+        <p:nvPr/>
+      </p:nvGrpSpPr>
+      <p:grpSpPr>
+        <a:xfrm>
+          <a:off x="0" y="0"/>
+          <a:ext cx="0" cy="0"/>
+          <a:chOff x="0" y="0"/>
+          <a:chExt cx="0" cy="0"/>
+        </a:xfrm>
+      </p:grpSpPr>
+      <p:sp>
+        <p:nvSpPr>
+          <p:cNvPr id="2" name="Titolo 1">
+            <a:extLst>
+              <a:ext uri="{FF2B5EF4-FFF2-40B4-BE49-F238E27FC236}">
+                <a16:creationId xmlns:a16="http://schemas.microsoft.com/office/drawing/2014/main" id="{459797B7-F415-46D1-EDB4-47FBDF26E77A}"/>
+              </a:ext>
+            </a:extLst>
+          </p:cNvPr>
+          <p:cNvSpPr>
+            <a:spLocks noGrp="1"/>
+          </p:cNvSpPr>
+          <p:nvPr>
+            <p:ph type="title"/>
+          </p:nvPr>
+        </p:nvSpPr>
+        <p:spPr>
+          <a:xfrm>
+            <a:off x="1126666" y="1060704"/>
+            <a:ext cx="8977511" cy="651960"/>
+          </a:xfrm>
+        </p:spPr>
+        <p:txBody>
+          <a:bodyPr/>
+          <a:lstStyle/>
+          <a:p>
+            <a:r>
+              <a:rPr lang="it-IT" dirty="0" err="1"/>
+              <a:t>Main</a:t>
+            </a:r>
+            <a:r>
+              <a:rPr lang="it-IT" dirty="0"/>
+              <a:t> STEPS</a:t>
+            </a:r>
+          </a:p>
+        </p:txBody>
+      </p:sp>
+      <p:sp>
+        <p:nvSpPr>
+          <p:cNvPr id="3" name="Segnaposto contenuto 2">
+            <a:extLst>
+              <a:ext uri="{FF2B5EF4-FFF2-40B4-BE49-F238E27FC236}">
+                <a16:creationId xmlns:a16="http://schemas.microsoft.com/office/drawing/2014/main" id="{9FA807A2-55EE-4F88-1DAC-B63433BA78C6}"/>
+              </a:ext>
+            </a:extLst>
+          </p:cNvPr>
+          <p:cNvSpPr>
+            <a:spLocks noGrp="1"/>
+          </p:cNvSpPr>
+          <p:nvPr>
+            <p:ph idx="1"/>
+          </p:nvPr>
+        </p:nvSpPr>
+        <p:spPr>
+          <a:xfrm>
+            <a:off x="1492428" y="2145319"/>
+            <a:ext cx="8977509" cy="3377657"/>
+          </a:xfrm>
+        </p:spPr>
+        <p:txBody>
+          <a:bodyPr>
+            <a:normAutofit/>
+          </a:bodyPr>
+          <a:lstStyle/>
+          <a:p>
+            <a:pPr marL="0" indent="0">
+              <a:buNone/>
+            </a:pPr>
+            <a:r>
+              <a:rPr lang="en-US" dirty="0"/>
+              <a:t>As previously observed, the </a:t>
+            </a:r>
+            <a:r>
+              <a:rPr lang="en-US" dirty="0" err="1"/>
+              <a:t>WiFi</a:t>
+            </a:r>
+            <a:r>
+              <a:rPr lang="en-US" dirty="0"/>
+              <a:t> repeater suffers from two known vulnerabilities: </a:t>
+            </a:r>
+            <a:r>
+              <a:rPr lang="en-US" b="1" dirty="0"/>
+              <a:t>CVE-2023-30404</a:t>
+            </a:r>
+            <a:r>
+              <a:rPr lang="en-US" dirty="0"/>
+              <a:t> and </a:t>
+            </a:r>
+            <a:r>
+              <a:rPr lang="en-US" b="1" dirty="0"/>
+              <a:t>CVE-2023-30405</a:t>
+            </a:r>
+            <a:r>
+              <a:rPr lang="en-US" dirty="0"/>
+              <a:t>.</a:t>
+            </a:r>
+            <a:br>
+              <a:rPr lang="en-US" dirty="0"/>
+            </a:br>
+            <a:r>
+              <a:rPr lang="en-US" dirty="0"/>
+              <a:t>Following the dump of the device’s EEPROM memory and an analysis of our possibilities, we defined the following steps:</a:t>
+            </a:r>
+          </a:p>
+          <a:p>
+            <a:r>
+              <a:rPr lang="en-US" b="1" dirty="0"/>
+              <a:t>Step 1: </a:t>
+            </a:r>
+            <a:r>
+              <a:rPr lang="en-US" dirty="0"/>
+              <a:t>Exploit the vulnerabilities to create an attack scenario in which we obtain full control of the device in order to attack other devices on the same network; </a:t>
+            </a:r>
+          </a:p>
+          <a:p>
+            <a:r>
+              <a:rPr lang="en-US" b="1" dirty="0"/>
+              <a:t>Step 2: </a:t>
+            </a:r>
+            <a:r>
+              <a:rPr lang="en-US" dirty="0"/>
+              <a:t>Firmware extraction and analysis;</a:t>
+            </a:r>
+          </a:p>
+          <a:p>
+            <a:r>
+              <a:rPr lang="en-US" b="1" dirty="0"/>
+              <a:t>Step 3: </a:t>
+            </a:r>
+            <a:r>
+              <a:rPr lang="en-US" dirty="0"/>
+              <a:t>Develop a firmware version in which we attempt to mitigate these vulnerabilities.</a:t>
+            </a:r>
+          </a:p>
+        </p:txBody>
+      </p:sp>
+    </p:spTree>
+    <p:extLst>
+      <p:ext uri="{BB962C8B-B14F-4D97-AF65-F5344CB8AC3E}">
+        <p14:creationId xmlns:p14="http://schemas.microsoft.com/office/powerpoint/2010/main" val="1958637281"/>
+      </p:ext>
+    </p:extLst>
+  </p:cSld>
+  <p:clrMapOvr>
+    <a:masterClrMapping/>
+  </p:clrMapOvr>
+</p:sld>
+</file>
+
+<file path=ppt/slides/slide4.xml><?xml version="1.0" encoding="utf-8"?>
+<p:sld xmlns:a="http://schemas.openxmlformats.org/drawingml/2006/main" xmlns:r="http://schemas.openxmlformats.org/officeDocument/2006/relationships" xmlns:p="http://schemas.openxmlformats.org/presentationml/2006/main">
+  <p:cSld>
+    <p:spTree>
+      <p:nvGrpSpPr>
+        <p:cNvPr id="1" name="">
+          <a:extLst>
+            <a:ext uri="{FF2B5EF4-FFF2-40B4-BE49-F238E27FC236}">
+              <a16:creationId xmlns:a16="http://schemas.microsoft.com/office/drawing/2014/main" id="{E1C3A3E1-1573-62EE-0066-8784AD7F6F76}"/>
+            </a:ext>
+          </a:extLst>
+        </p:cNvPr>
+        <p:cNvGrpSpPr/>
+        <p:nvPr/>
+      </p:nvGrpSpPr>
+      <p:grpSpPr>
+        <a:xfrm>
+          <a:off x="0" y="0"/>
+          <a:ext cx="0" cy="0"/>
+          <a:chOff x="0" y="0"/>
+          <a:chExt cx="0" cy="0"/>
+        </a:xfrm>
+      </p:grpSpPr>
+      <p:sp>
+        <p:nvSpPr>
+          <p:cNvPr id="2" name="Titolo 1">
+            <a:extLst>
+              <a:ext uri="{FF2B5EF4-FFF2-40B4-BE49-F238E27FC236}">
+                <a16:creationId xmlns:a16="http://schemas.microsoft.com/office/drawing/2014/main" id="{73A905BF-D388-EA48-A927-EB2560823325}"/>
+              </a:ext>
+            </a:extLst>
+          </p:cNvPr>
+          <p:cNvSpPr>
+            <a:spLocks noGrp="1"/>
+          </p:cNvSpPr>
+          <p:nvPr>
+            <p:ph type="title"/>
+          </p:nvPr>
+        </p:nvSpPr>
+        <p:spPr>
+          <a:xfrm>
+            <a:off x="1126666" y="1060704"/>
+            <a:ext cx="8977511" cy="651960"/>
+          </a:xfrm>
+        </p:spPr>
+        <p:txBody>
+          <a:bodyPr/>
+          <a:lstStyle/>
+          <a:p>
+            <a:r>
+              <a:rPr lang="it-IT" dirty="0"/>
+              <a:t>STEP 1</a:t>
+            </a:r>
+          </a:p>
+        </p:txBody>
+      </p:sp>
+      <p:sp>
+        <p:nvSpPr>
+          <p:cNvPr id="3" name="Segnaposto contenuto 2">
+            <a:extLst>
+              <a:ext uri="{FF2B5EF4-FFF2-40B4-BE49-F238E27FC236}">
+                <a16:creationId xmlns:a16="http://schemas.microsoft.com/office/drawing/2014/main" id="{E6DFE84D-ECB3-EEA7-F47E-329C9438C9A5}"/>
+              </a:ext>
+            </a:extLst>
+          </p:cNvPr>
+          <p:cNvSpPr>
+            <a:spLocks noGrp="1"/>
+          </p:cNvSpPr>
+          <p:nvPr>
+            <p:ph idx="1"/>
+          </p:nvPr>
+        </p:nvSpPr>
+        <p:spPr>
+          <a:xfrm>
+            <a:off x="1492428" y="2145319"/>
+            <a:ext cx="8977509" cy="3377657"/>
+          </a:xfrm>
+        </p:spPr>
+        <p:txBody>
+          <a:bodyPr>
+            <a:normAutofit fontScale="92500" lnSpcReduction="20000"/>
+          </a:bodyPr>
+          <a:lstStyle/>
+          <a:p>
+            <a:pPr marL="0" indent="0">
+              <a:buNone/>
+            </a:pPr>
+            <a:r>
+              <a:rPr lang="en-US" dirty="0"/>
+              <a:t>The first step involves exploiting a </a:t>
+            </a:r>
+            <a:r>
+              <a:rPr lang="en-US" b="1" dirty="0"/>
+              <a:t>Remote Code Execution (RCE) </a:t>
+            </a:r>
+            <a:r>
+              <a:rPr lang="en-US" dirty="0"/>
+              <a:t>vulnerability present in the firmware of the IoT device. </a:t>
+            </a:r>
+          </a:p>
+          <a:p>
+            <a:r>
+              <a:rPr lang="en-US" dirty="0"/>
+              <a:t>Through this vulnerability, we achieve the execution of arbitrary code on the embedded system and obtain a reverse shell toward an externally controlled machine. </a:t>
+            </a:r>
+          </a:p>
+          <a:p>
+            <a:r>
+              <a:rPr lang="en-US" dirty="0"/>
+              <a:t>This allows persistent remote access and administrative control over the device.</a:t>
+            </a:r>
+          </a:p>
+          <a:p>
+            <a:pPr marL="0" indent="0">
+              <a:buNone/>
+            </a:pPr>
+            <a:r>
+              <a:rPr lang="en-US" dirty="0"/>
+              <a:t>Subsequently, the compromised device is used as a point to perform a </a:t>
+            </a:r>
+            <a:r>
+              <a:rPr lang="en-US" b="1" dirty="0"/>
+              <a:t>Man-in-the-Middle (MITM) </a:t>
+            </a:r>
+            <a:r>
+              <a:rPr lang="en-US" dirty="0"/>
+              <a:t>attack through </a:t>
+            </a:r>
+            <a:r>
+              <a:rPr lang="en-US" b="1" dirty="0"/>
+              <a:t>ARP poisoning</a:t>
+            </a:r>
+            <a:r>
+              <a:rPr lang="en-US" dirty="0"/>
+              <a:t>. </a:t>
+            </a:r>
+          </a:p>
+          <a:p>
+            <a:r>
+              <a:rPr lang="en-US" dirty="0"/>
+              <a:t>This enables the interception of network traffic in order to identify sensitive </a:t>
+            </a:r>
+            <a:r>
+              <a:rPr lang="en-US" b="1" dirty="0"/>
+              <a:t>data and credentials</a:t>
+            </a:r>
+            <a:r>
+              <a:rPr lang="en-US" dirty="0"/>
+              <a:t>, while forwarding the packets to their original destination to maintain the transparency of the attack</a:t>
+            </a:r>
+            <a:r>
+              <a:rPr lang="en-US" b="1" dirty="0"/>
+              <a:t>.</a:t>
+            </a:r>
+            <a:endParaRPr lang="en-US" dirty="0"/>
+          </a:p>
+        </p:txBody>
+      </p:sp>
+    </p:spTree>
+    <p:extLst>
+      <p:ext uri="{BB962C8B-B14F-4D97-AF65-F5344CB8AC3E}">
+        <p14:creationId xmlns:p14="http://schemas.microsoft.com/office/powerpoint/2010/main" val="970535834"/>
+      </p:ext>
+    </p:extLst>
+  </p:cSld>
+  <p:clrMapOvr>
+    <a:masterClrMapping/>
+  </p:clrMapOvr>
+</p:sld>
+</file>
+
+<file path=ppt/slides/slide5.xml><?xml version="1.0" encoding="utf-8"?>
+<p:sld xmlns:a="http://schemas.openxmlformats.org/drawingml/2006/main" xmlns:r="http://schemas.openxmlformats.org/officeDocument/2006/relationships" xmlns:p="http://schemas.openxmlformats.org/presentationml/2006/main">
+  <p:cSld>
+    <p:spTree>
+      <p:nvGrpSpPr>
         <p:cNvPr id="1" name=""/>
         <p:cNvGrpSpPr/>
         <p:nvPr/>
@@ -5077,7 +5338,7 @@
           <p:cNvPr id="2" name="Titolo 1">
             <a:extLst>
               <a:ext uri="{FF2B5EF4-FFF2-40B4-BE49-F238E27FC236}">
-                <a16:creationId xmlns:a16="http://schemas.microsoft.com/office/drawing/2014/main" id="{8BD87E4A-4250-94CF-E4F3-E4477476C883}"/>
+                <a16:creationId xmlns:a16="http://schemas.microsoft.com/office/drawing/2014/main" id="{0BA48CF9-C54D-BB0F-4E86-1CB353C5FD5D}"/>
               </a:ext>
             </a:extLst>
           </p:cNvPr>
@@ -5088,14 +5349,19 @@
             <p:ph type="title"/>
           </p:nvPr>
         </p:nvSpPr>
-        <p:spPr/>
+        <p:spPr>
+          <a:xfrm>
+            <a:off x="1126666" y="1060704"/>
+            <a:ext cx="8977511" cy="651960"/>
+          </a:xfrm>
+        </p:spPr>
         <p:txBody>
           <a:bodyPr/>
           <a:lstStyle/>
           <a:p>
             <a:r>
               <a:rPr lang="it-IT" dirty="0"/>
-              <a:t>Obiettivo</a:t>
+              <a:t>STEP 2</a:t>
             </a:r>
           </a:p>
         </p:txBody>
@@ -5105,7 +5371,7 @@
           <p:cNvPr id="3" name="Segnaposto contenuto 2">
             <a:extLst>
               <a:ext uri="{FF2B5EF4-FFF2-40B4-BE49-F238E27FC236}">
-                <a16:creationId xmlns:a16="http://schemas.microsoft.com/office/drawing/2014/main" id="{E4F83AA7-ED29-DE5B-D7AB-60126D1F807A}"/>
+                <a16:creationId xmlns:a16="http://schemas.microsoft.com/office/drawing/2014/main" id="{F92571AE-B527-8675-C0F3-22607D39EC1C}"/>
               </a:ext>
             </a:extLst>
           </p:cNvPr>
@@ -5116,76 +5382,110 @@
             <p:ph idx="1"/>
           </p:nvPr>
         </p:nvSpPr>
-        <p:spPr/>
-        <p:txBody>
-          <a:bodyPr/>
+        <p:spPr>
+          <a:xfrm>
+            <a:off x="1492428" y="2145319"/>
+            <a:ext cx="8977509" cy="3377657"/>
+          </a:xfrm>
+        </p:spPr>
+        <p:txBody>
+          <a:bodyPr>
+            <a:normAutofit fontScale="92500" lnSpcReduction="10000"/>
+          </a:bodyPr>
           <a:lstStyle/>
           <a:p>
             <a:pPr marL="0" indent="0">
               <a:buNone/>
             </a:pPr>
             <a:r>
-              <a:rPr lang="it-IT" dirty="0"/>
-              <a:t>Come visto in precedenza, il </a:t>
-            </a:r>
-            <a:r>
-              <a:rPr lang="it-IT" dirty="0" err="1"/>
-              <a:t>wifi</a:t>
-            </a:r>
-            <a:r>
-              <a:rPr lang="it-IT" dirty="0"/>
-              <a:t> </a:t>
-            </a:r>
-            <a:r>
-              <a:rPr lang="it-IT" dirty="0" err="1"/>
-              <a:t>repeater</a:t>
-            </a:r>
-            <a:r>
-              <a:rPr lang="it-IT" dirty="0"/>
-              <a:t> soffre di due vulnerabilità note: CVE-2023-30404 e CVE-2023-30405. </a:t>
-            </a:r>
-            <a:br>
-              <a:rPr lang="it-IT" dirty="0"/>
-            </a:br>
-            <a:r>
-              <a:rPr lang="it-IT" dirty="0"/>
-              <a:t>Successivamente al </a:t>
-            </a:r>
-            <a:r>
-              <a:rPr lang="it-IT" dirty="0" err="1"/>
-              <a:t>dump</a:t>
-            </a:r>
-            <a:r>
-              <a:rPr lang="it-IT" dirty="0"/>
-              <a:t> della memoria </a:t>
-            </a:r>
-            <a:r>
-              <a:rPr lang="it-IT" dirty="0" err="1"/>
-              <a:t>eeprom</a:t>
-            </a:r>
-            <a:r>
-              <a:rPr lang="it-IT" dirty="0"/>
-              <a:t> del dispositivo, abbiamo delineato i seguenti dispositivi:</a:t>
-            </a:r>
-          </a:p>
-          <a:p>
-            <a:r>
-              <a:rPr lang="it-IT" dirty="0"/>
-              <a:t>Sfruttare le vulnerabilità per creare uno scenario d’attacco in cui otteniamo il controllo completo del dispositivo per poter attaccare altri dispositivi sulla stessa rete;</a:t>
-            </a:r>
-          </a:p>
-          <a:p>
-            <a:r>
-              <a:rPr lang="it-IT" dirty="0"/>
-              <a:t>Creare un firmware in cui tentiamo di porre rimedio alle vulnerabilità.</a:t>
-            </a:r>
+              <a:rPr lang="en-US" dirty="0"/>
+              <a:t>The second step consists of extracting the firmware directly from the device’s non-volatile memory (EEPROM/flash) through a hardware interface (SOIC clip), preserving its contents without physically removing the chip.</a:t>
+            </a:r>
+          </a:p>
+          <a:p>
+            <a:pPr marL="0" indent="0">
+              <a:buNone/>
+            </a:pPr>
+            <a:r>
+              <a:rPr lang="en-US" dirty="0"/>
+              <a:t>The extracted firmware is then analyzed in order to:</a:t>
+            </a:r>
+          </a:p>
+          <a:p>
+            <a:r>
+              <a:rPr lang="en-US" dirty="0"/>
+              <a:t>identify the </a:t>
+            </a:r>
+            <a:r>
+              <a:rPr lang="en-US" b="1" dirty="0"/>
+              <a:t>internal structure </a:t>
+            </a:r>
+            <a:r>
+              <a:rPr lang="en-US" dirty="0"/>
+              <a:t>and </a:t>
+            </a:r>
+            <a:r>
+              <a:rPr lang="en-US" b="1" dirty="0"/>
+              <a:t>filesystem</a:t>
+            </a:r>
+            <a:r>
+              <a:rPr lang="en-US" dirty="0"/>
+              <a:t>;</a:t>
+            </a:r>
+          </a:p>
+          <a:p>
+            <a:r>
+              <a:rPr lang="en-US" dirty="0"/>
+              <a:t>locate the </a:t>
+            </a:r>
+            <a:r>
+              <a:rPr lang="en-US" b="1" dirty="0"/>
+              <a:t>vulnerable binary components </a:t>
+            </a:r>
+            <a:r>
+              <a:rPr lang="en-US" dirty="0"/>
+              <a:t>related to both the RCE and XSS vulnerabilities;</a:t>
+            </a:r>
+          </a:p>
+          <a:p>
+            <a:r>
+              <a:rPr lang="en-US" dirty="0"/>
+              <a:t>understand the execution flows involved in the vulnerability.</a:t>
+            </a:r>
+          </a:p>
+          <a:p>
+            <a:pPr marL="0" indent="0">
+              <a:buNone/>
+            </a:pPr>
+            <a:r>
+              <a:rPr lang="en-US" dirty="0"/>
+              <a:t>This phase provides a complete view of the device’s software and constitutes the foundation for mitigation activities without relying on the original source code.</a:t>
+            </a:r>
+          </a:p>
+          <a:p>
+            <a:pPr marL="0" indent="0">
+              <a:buNone/>
+            </a:pPr>
+            <a:endParaRPr lang="it-IT" dirty="0"/>
+          </a:p>
+          <a:p>
+            <a:pPr marL="0" indent="0">
+              <a:buNone/>
+            </a:pPr>
+            <a:endParaRPr lang="it-IT" dirty="0"/>
+          </a:p>
+          <a:p>
+            <a:pPr marL="0" indent="0">
+              <a:buNone/>
+            </a:pPr>
+            <a:endParaRPr lang="it-IT" dirty="0"/>
           </a:p>
         </p:txBody>
       </p:sp>
     </p:spTree>
     <p:extLst>
       <p:ext uri="{BB962C8B-B14F-4D97-AF65-F5344CB8AC3E}">
-        <p14:creationId xmlns:p14="http://schemas.microsoft.com/office/powerpoint/2010/main" val="2068480627"/>
+        <p14:creationId xmlns:p14="http://schemas.microsoft.com/office/powerpoint/2010/main" val="1266634406"/>
       </p:ext>
     </p:extLst>
   </p:cSld>
@@ -5195,7 +5495,189 @@
 </p:sld>
 </file>
 
-<file path=ppt/slides/slide4.xml><?xml version="1.0" encoding="utf-8"?>
+<file path=ppt/slides/slide6.xml><?xml version="1.0" encoding="utf-8"?>
+<p:sld xmlns:a="http://schemas.openxmlformats.org/drawingml/2006/main" xmlns:r="http://schemas.openxmlformats.org/officeDocument/2006/relationships" xmlns:p="http://schemas.openxmlformats.org/presentationml/2006/main">
+  <p:cSld>
+    <p:spTree>
+      <p:nvGrpSpPr>
+        <p:cNvPr id="1" name="">
+          <a:extLst>
+            <a:ext uri="{FF2B5EF4-FFF2-40B4-BE49-F238E27FC236}">
+              <a16:creationId xmlns:a16="http://schemas.microsoft.com/office/drawing/2014/main" id="{EDE9F007-3CE4-5315-AC8C-30459E26F4EB}"/>
+            </a:ext>
+          </a:extLst>
+        </p:cNvPr>
+        <p:cNvGrpSpPr/>
+        <p:nvPr/>
+      </p:nvGrpSpPr>
+      <p:grpSpPr>
+        <a:xfrm>
+          <a:off x="0" y="0"/>
+          <a:ext cx="0" cy="0"/>
+          <a:chOff x="0" y="0"/>
+          <a:chExt cx="0" cy="0"/>
+        </a:xfrm>
+      </p:grpSpPr>
+      <p:sp>
+        <p:nvSpPr>
+          <p:cNvPr id="2" name="Titolo 1">
+            <a:extLst>
+              <a:ext uri="{FF2B5EF4-FFF2-40B4-BE49-F238E27FC236}">
+                <a16:creationId xmlns:a16="http://schemas.microsoft.com/office/drawing/2014/main" id="{DB886F98-69A9-4B04-C930-4B57F716360E}"/>
+              </a:ext>
+            </a:extLst>
+          </p:cNvPr>
+          <p:cNvSpPr>
+            <a:spLocks noGrp="1"/>
+          </p:cNvSpPr>
+          <p:nvPr>
+            <p:ph type="title"/>
+          </p:nvPr>
+        </p:nvSpPr>
+        <p:spPr>
+          <a:xfrm>
+            <a:off x="1126666" y="1060704"/>
+            <a:ext cx="8977511" cy="651960"/>
+          </a:xfrm>
+        </p:spPr>
+        <p:txBody>
+          <a:bodyPr/>
+          <a:lstStyle/>
+          <a:p>
+            <a:r>
+              <a:rPr lang="it-IT" dirty="0"/>
+              <a:t>STEP 3</a:t>
+            </a:r>
+          </a:p>
+        </p:txBody>
+      </p:sp>
+      <p:sp>
+        <p:nvSpPr>
+          <p:cNvPr id="3" name="Segnaposto contenuto 2">
+            <a:extLst>
+              <a:ext uri="{FF2B5EF4-FFF2-40B4-BE49-F238E27FC236}">
+                <a16:creationId xmlns:a16="http://schemas.microsoft.com/office/drawing/2014/main" id="{ABA206C5-2B41-8A97-728E-24819F04ABE9}"/>
+              </a:ext>
+            </a:extLst>
+          </p:cNvPr>
+          <p:cNvSpPr>
+            <a:spLocks noGrp="1"/>
+          </p:cNvSpPr>
+          <p:nvPr>
+            <p:ph idx="1"/>
+          </p:nvPr>
+        </p:nvSpPr>
+        <p:spPr>
+          <a:xfrm>
+            <a:off x="1492428" y="2145319"/>
+            <a:ext cx="8977509" cy="3377657"/>
+          </a:xfrm>
+        </p:spPr>
+        <p:txBody>
+          <a:bodyPr>
+            <a:normAutofit fontScale="92500" lnSpcReduction="10000"/>
+          </a:bodyPr>
+          <a:lstStyle/>
+          <a:p>
+            <a:r>
+              <a:rPr lang="en-US" dirty="0"/>
+              <a:t>The </a:t>
+            </a:r>
+            <a:r>
+              <a:rPr lang="en-US" b="1" dirty="0"/>
+              <a:t>RCE vulnerability </a:t>
+            </a:r>
+            <a:r>
+              <a:rPr lang="en-US" dirty="0"/>
+              <a:t>is caused by an unused function within the firmware that was not removed by the developer.</a:t>
+            </a:r>
+          </a:p>
+          <a:p>
+            <a:r>
+              <a:rPr lang="en-US" dirty="0"/>
+              <a:t>The </a:t>
+            </a:r>
+            <a:r>
+              <a:rPr lang="en-US" b="1" dirty="0"/>
+              <a:t>XSS vulnerability</a:t>
+            </a:r>
+            <a:r>
+              <a:rPr lang="en-US" dirty="0"/>
+              <a:t>, on the other hand, results from the absence of proper input sanitization during the handling of web requests.</a:t>
+            </a:r>
+          </a:p>
+          <a:p>
+            <a:pPr marL="0" indent="0">
+              <a:buNone/>
+            </a:pPr>
+            <a:r>
+              <a:rPr lang="en-US" dirty="0"/>
+              <a:t>To address these issues, the firmware must be patched by performing </a:t>
+            </a:r>
+            <a:r>
+              <a:rPr lang="en-US" b="1" dirty="0"/>
+              <a:t>binary patching </a:t>
+            </a:r>
+            <a:r>
+              <a:rPr lang="en-US" dirty="0"/>
+              <a:t>of the code.</a:t>
+            </a:r>
+          </a:p>
+          <a:p>
+            <a:r>
+              <a:rPr lang="en-US" dirty="0"/>
+              <a:t>The firmware update will be carried out through two possible approaches:</a:t>
+            </a:r>
+          </a:p>
+          <a:p>
+            <a:pPr marL="342900" indent="-342900">
+              <a:buFont typeface="+mj-lt"/>
+              <a:buAutoNum type="arabicPeriod"/>
+            </a:pPr>
+            <a:r>
+              <a:rPr lang="en-US" dirty="0"/>
+              <a:t>flashing the EEPROM memory;</a:t>
+            </a:r>
+          </a:p>
+          <a:p>
+            <a:pPr marL="342900" indent="-342900">
+              <a:buFont typeface="+mj-lt"/>
+              <a:buAutoNum type="arabicPeriod"/>
+            </a:pPr>
+            <a:r>
+              <a:rPr lang="en-US" dirty="0"/>
+              <a:t>using the device’s web interface for firmware updates.</a:t>
+            </a:r>
+          </a:p>
+          <a:p>
+            <a:pPr marL="342900" indent="-342900">
+              <a:buFont typeface="+mj-lt"/>
+              <a:buAutoNum type="arabicPeriod"/>
+            </a:pPr>
+            <a:endParaRPr lang="it-IT" dirty="0"/>
+          </a:p>
+          <a:p>
+            <a:pPr marL="0" indent="0">
+              <a:buNone/>
+            </a:pPr>
+            <a:endParaRPr lang="it-IT" dirty="0"/>
+          </a:p>
+        </p:txBody>
+      </p:sp>
+    </p:spTree>
+    <p:extLst>
+      <p:ext uri="{BB962C8B-B14F-4D97-AF65-F5344CB8AC3E}">
+        <p14:creationId xmlns:p14="http://schemas.microsoft.com/office/powerpoint/2010/main" val="2167845699"/>
+      </p:ext>
+    </p:extLst>
+  </p:cSld>
+  <p:clrMapOvr>
+    <a:masterClrMapping/>
+  </p:clrMapOvr>
+</p:sld>
+</file>
+
+<file path=ppt/slides/slide7.xml><?xml version="1.0" encoding="utf-8"?>
 <p:sld xmlns:a="http://schemas.openxmlformats.org/drawingml/2006/main" xmlns:r="http://schemas.openxmlformats.org/officeDocument/2006/relationships" xmlns:p="http://schemas.openxmlformats.org/presentationml/2006/main">
   <p:cSld>
     <p:bg>

</xml_diff>